<commit_message>
Added slide on Fourier transform
</commit_message>
<xml_diff>
--- a/lecture-timeseries.pptx
+++ b/lecture-timeseries.pptx
@@ -5,10 +5,10 @@
     <p:sldMasterId id="2147483648" r:id="rId4"/>
   </p:sldMasterIdLst>
   <p:notesMasterIdLst>
-    <p:notesMasterId r:id="rId19"/>
+    <p:notesMasterId r:id="rId20"/>
   </p:notesMasterIdLst>
   <p:handoutMasterIdLst>
-    <p:handoutMasterId r:id="rId20"/>
+    <p:handoutMasterId r:id="rId21"/>
   </p:handoutMasterIdLst>
   <p:sldIdLst>
     <p:sldId id="257" r:id="rId5"/>
@@ -25,6 +25,7 @@
     <p:sldId id="290" r:id="rId16"/>
     <p:sldId id="291" r:id="rId17"/>
     <p:sldId id="292" r:id="rId18"/>
+    <p:sldId id="293" r:id="rId19"/>
   </p:sldIdLst>
   <p:sldSz cx="9144000" cy="6858000" type="screen4x3"/>
   <p:notesSz cx="6858000" cy="9144000"/>
@@ -254,7 +255,7 @@
           <a:p>
             <a:fld id="{1ED7098F-87C7-3046-B8E1-0317C0D8D9C4}" type="datetimeFigureOut">
               <a:rPr lang="en-US" smtClean="0"/>
-              <a:t>2/21/26</a:t>
+              <a:t>9/21/26</a:t>
             </a:fld>
             <a:endParaRPr lang="en-US"/>
           </a:p>
@@ -420,7 +421,7 @@
           <a:p>
             <a:fld id="{A83074A2-D88D-8F43-B619-246CA3905610}" type="datetimeFigureOut">
               <a:rPr lang="en-US" smtClean="0"/>
-              <a:t>2/21/26</a:t>
+              <a:t>9/21/26</a:t>
             </a:fld>
             <a:endParaRPr lang="en-US"/>
           </a:p>
@@ -2433,7 +2434,7 @@
                     <m:f>
                       <m:fPr>
                         <m:ctrlPr>
-                          <a:rPr lang="nl-NL" i="1" smtClean="0">
+                          <a:rPr lang="nl-NL" b="0" i="1" smtClean="0">
                             <a:latin typeface="Cambria Math" panose="02040503050406030204" pitchFamily="18" charset="0"/>
                           </a:rPr>
                         </m:ctrlPr>
@@ -2459,7 +2460,7 @@
                       <m:naryPr>
                         <m:chr m:val="∑"/>
                         <m:ctrlPr>
-                          <a:rPr lang="nl-NL" i="1" smtClean="0">
+                          <a:rPr lang="nl-NL" b="0" i="1" smtClean="0">
                             <a:latin typeface="Cambria Math" panose="02040503050406030204" pitchFamily="18" charset="0"/>
                           </a:rPr>
                         </m:ctrlPr>
@@ -4720,6 +4721,259 @@
 </p:sld>
 </file>
 
+<file path=ppt/slides/slide15.xml><?xml version="1.0" encoding="utf-8"?>
+<p:sld xmlns:a="http://schemas.openxmlformats.org/drawingml/2006/main" xmlns:r="http://schemas.openxmlformats.org/officeDocument/2006/relationships" xmlns:p="http://schemas.openxmlformats.org/presentationml/2006/main">
+  <p:cSld>
+    <p:spTree>
+      <p:nvGrpSpPr>
+        <p:cNvPr id="1" name=""/>
+        <p:cNvGrpSpPr/>
+        <p:nvPr/>
+      </p:nvGrpSpPr>
+      <p:grpSpPr>
+        <a:xfrm>
+          <a:off x="0" y="0"/>
+          <a:ext cx="0" cy="0"/>
+          <a:chOff x="0" y="0"/>
+          <a:chExt cx="0" cy="0"/>
+        </a:xfrm>
+      </p:grpSpPr>
+      <p:sp>
+        <p:nvSpPr>
+          <p:cNvPr id="2" name="Tijdelijke aanduiding voor tekst 1">
+            <a:extLst>
+              <a:ext uri="{FF2B5EF4-FFF2-40B4-BE49-F238E27FC236}">
+                <a16:creationId xmlns:a16="http://schemas.microsoft.com/office/drawing/2014/main" id="{8167C692-12F7-0D7C-99B5-14D840ADE5C5}"/>
+              </a:ext>
+            </a:extLst>
+          </p:cNvPr>
+          <p:cNvSpPr>
+            <a:spLocks noGrp="1"/>
+          </p:cNvSpPr>
+          <p:nvPr>
+            <p:ph type="body" sz="quarter" idx="10"/>
+          </p:nvPr>
+        </p:nvSpPr>
+        <p:spPr>
+          <a:xfrm>
+            <a:off x="628650" y="1925638"/>
+            <a:ext cx="4087729" cy="4259262"/>
+          </a:xfrm>
+        </p:spPr>
+        <p:txBody>
+          <a:bodyPr/>
+          <a:lstStyle/>
+          <a:p>
+            <a:pPr marL="342900" indent="-342900">
+              <a:buFont typeface="Arial" panose="020B0604020202020204" pitchFamily="34" charset="0"/>
+              <a:buChar char="•"/>
+            </a:pPr>
+            <a:r>
+              <a:rPr lang="en-US" dirty="0"/>
+              <a:t>Approximate a signal by adding sine waves together.</a:t>
+            </a:r>
+          </a:p>
+          <a:p>
+            <a:pPr marL="342900" indent="-342900">
+              <a:buFont typeface="Arial" panose="020B0604020202020204" pitchFamily="34" charset="0"/>
+              <a:buChar char="•"/>
+            </a:pPr>
+            <a:r>
+              <a:rPr lang="en-US" dirty="0"/>
+              <a:t>Can be much better than “trend + seasonality” time series.</a:t>
+            </a:r>
+          </a:p>
+          <a:p>
+            <a:pPr marL="342900" indent="-342900">
+              <a:buFont typeface="Arial" panose="020B0604020202020204" pitchFamily="34" charset="0"/>
+              <a:buChar char="•"/>
+            </a:pPr>
+            <a:r>
+              <a:rPr lang="en-US" dirty="0"/>
+              <a:t>Computationally expensive</a:t>
+            </a:r>
+          </a:p>
+          <a:p>
+            <a:pPr marL="342900" indent="-342900">
+              <a:buFont typeface="Arial" panose="020B0604020202020204" pitchFamily="34" charset="0"/>
+              <a:buChar char="•"/>
+            </a:pPr>
+            <a:r>
+              <a:rPr lang="en-US" dirty="0"/>
+              <a:t>Risk of overfitting</a:t>
+            </a:r>
+          </a:p>
+          <a:p>
+            <a:pPr marL="342900" indent="-342900">
+              <a:buFont typeface="Arial" panose="020B0604020202020204" pitchFamily="34" charset="0"/>
+              <a:buChar char="•"/>
+            </a:pPr>
+            <a:endParaRPr lang="en-US" dirty="0"/>
+          </a:p>
+          <a:p>
+            <a:pPr marL="342900" indent="-342900">
+              <a:buFont typeface="Arial" panose="020B0604020202020204" pitchFamily="34" charset="0"/>
+              <a:buChar char="•"/>
+            </a:pPr>
+            <a:r>
+              <a:rPr lang="en-US" dirty="0"/>
+              <a:t>If you must use Fourier analysis:</a:t>
+            </a:r>
+          </a:p>
+          <a:p>
+            <a:pPr marL="728653" lvl="1" indent="-342900"/>
+            <a:r>
+              <a:rPr lang="en-US" dirty="0"/>
+              <a:t>Filter beforehand (why?).</a:t>
+            </a:r>
+          </a:p>
+          <a:p>
+            <a:pPr marL="728653" lvl="1" indent="-342900"/>
+            <a:r>
+              <a:rPr lang="en-US" dirty="0"/>
+              <a:t>Provide a large test set to check if you’re overfitting.</a:t>
+            </a:r>
+          </a:p>
+        </p:txBody>
+      </p:sp>
+      <p:sp>
+        <p:nvSpPr>
+          <p:cNvPr id="3" name="Titel 2">
+            <a:extLst>
+              <a:ext uri="{FF2B5EF4-FFF2-40B4-BE49-F238E27FC236}">
+                <a16:creationId xmlns:a16="http://schemas.microsoft.com/office/drawing/2014/main" id="{EE993865-A96A-09B2-FF04-87BA7B3FCDAF}"/>
+              </a:ext>
+            </a:extLst>
+          </p:cNvPr>
+          <p:cNvSpPr>
+            <a:spLocks noGrp="1"/>
+          </p:cNvSpPr>
+          <p:nvPr>
+            <p:ph type="title"/>
+          </p:nvPr>
+        </p:nvSpPr>
+        <p:spPr/>
+        <p:txBody>
+          <a:bodyPr/>
+          <a:lstStyle/>
+          <a:p>
+            <a:r>
+              <a:rPr lang="en-US" dirty="0"/>
+              <a:t>Fourier Analysis</a:t>
+            </a:r>
+          </a:p>
+        </p:txBody>
+      </p:sp>
+      <p:pic>
+        <p:nvPicPr>
+          <p:cNvPr id="5" name="Afbeelding 4">
+            <a:extLst>
+              <a:ext uri="{FF2B5EF4-FFF2-40B4-BE49-F238E27FC236}">
+                <a16:creationId xmlns:a16="http://schemas.microsoft.com/office/drawing/2014/main" id="{5FA4A541-F0C6-5BEE-1E71-420F53238C6A}"/>
+              </a:ext>
+            </a:extLst>
+          </p:cNvPr>
+          <p:cNvPicPr>
+            <a:picLocks noChangeAspect="1"/>
+          </p:cNvPicPr>
+          <p:nvPr/>
+        </p:nvPicPr>
+        <p:blipFill>
+          <a:blip r:embed="rId2"/>
+          <a:stretch>
+            <a:fillRect/>
+          </a:stretch>
+        </p:blipFill>
+        <p:spPr>
+          <a:xfrm>
+            <a:off x="4940968" y="1690692"/>
+            <a:ext cx="3704055" cy="3755398"/>
+          </a:xfrm>
+          <a:prstGeom prst="rect">
+            <a:avLst/>
+          </a:prstGeom>
+        </p:spPr>
+      </p:pic>
+      <p:sp>
+        <p:nvSpPr>
+          <p:cNvPr id="6" name="Tekstvak 5">
+            <a:extLst>
+              <a:ext uri="{FF2B5EF4-FFF2-40B4-BE49-F238E27FC236}">
+                <a16:creationId xmlns:a16="http://schemas.microsoft.com/office/drawing/2014/main" id="{12542EB8-EE52-804C-6131-90427A4690B7}"/>
+              </a:ext>
+            </a:extLst>
+          </p:cNvPr>
+          <p:cNvSpPr txBox="1"/>
+          <p:nvPr/>
+        </p:nvSpPr>
+        <p:spPr>
+          <a:xfrm>
+            <a:off x="2768264" y="5600306"/>
+            <a:ext cx="5747086" cy="400110"/>
+          </a:xfrm>
+          <a:prstGeom prst="rect">
+            <a:avLst/>
+          </a:prstGeom>
+          <a:noFill/>
+        </p:spPr>
+        <p:txBody>
+          <a:bodyPr wrap="none" rtlCol="0">
+            <a:spAutoFit/>
+          </a:bodyPr>
+          <a:lstStyle/>
+          <a:p>
+            <a:pPr algn="r"/>
+            <a:r>
+              <a:rPr lang="en-US" sz="1000" dirty="0"/>
+              <a:t>Image source: </a:t>
+            </a:r>
+            <a:br>
+              <a:rPr lang="en-US" sz="1000" dirty="0"/>
+            </a:br>
+            <a:r>
+              <a:rPr lang="en-US" sz="1000" dirty="0"/>
+              <a:t>https://</a:t>
+            </a:r>
+            <a:r>
+              <a:rPr lang="en-US" sz="1000" dirty="0" err="1"/>
+              <a:t>sites.northwestern.edu</a:t>
+            </a:r>
+            <a:r>
+              <a:rPr lang="en-US" sz="1000" dirty="0"/>
+              <a:t>/</a:t>
+            </a:r>
+            <a:r>
+              <a:rPr lang="en-US" sz="1000" dirty="0" err="1"/>
+              <a:t>elannesscohn</a:t>
+            </a:r>
+            <a:r>
+              <a:rPr lang="en-US" sz="1000" dirty="0"/>
+              <a:t>/2019/07/30/developing-an-intuition-for-</a:t>
+            </a:r>
+            <a:r>
+              <a:rPr lang="en-US" sz="1000" dirty="0" err="1"/>
+              <a:t>fourier</a:t>
+            </a:r>
+            <a:r>
+              <a:rPr lang="en-US" sz="1000" dirty="0"/>
+              <a:t>-transforms/</a:t>
+            </a:r>
+          </a:p>
+        </p:txBody>
+      </p:sp>
+    </p:spTree>
+    <p:extLst>
+      <p:ext uri="{BB962C8B-B14F-4D97-AF65-F5344CB8AC3E}">
+        <p14:creationId xmlns:p14="http://schemas.microsoft.com/office/powerpoint/2010/main" val="813162637"/>
+      </p:ext>
+    </p:extLst>
+  </p:cSld>
+  <p:clrMapOvr>
+    <a:masterClrMapping/>
+  </p:clrMapOvr>
+</p:sld>
+</file>
+
 <file path=ppt/slides/slide2.xml><?xml version="1.0" encoding="utf-8"?>
 <p:sld xmlns:a="http://schemas.openxmlformats.org/drawingml/2006/main" xmlns:r="http://schemas.openxmlformats.org/officeDocument/2006/relationships" xmlns:p="http://schemas.openxmlformats.org/presentationml/2006/main">
   <p:cSld>
@@ -6166,8 +6420,8 @@
           <a:chExt cx="0" cy="0"/>
         </a:xfrm>
       </p:grpSpPr>
-      <mc:AlternateContent xmlns:mc="http://schemas.openxmlformats.org/markup-compatibility/2006">
-        <mc:Choice xmlns:a14="http://schemas.microsoft.com/office/drawing/2010/main" Requires="a14">
+      <mc:AlternateContent xmlns:mc="http://schemas.openxmlformats.org/markup-compatibility/2006" xmlns:a14="http://schemas.microsoft.com/office/drawing/2010/main">
+        <mc:Choice Requires="a14">
           <p:sp>
             <p:nvSpPr>
               <p:cNvPr id="2" name="Tijdelijke aanduiding voor tekst 1">
@@ -6356,7 +6610,7 @@
                       <m:accPr>
                         <m:chr m:val="̂"/>
                         <m:ctrlPr>
-                          <a:rPr lang="en-US" i="1" smtClean="0">
+                          <a:rPr lang="nl-NL" b="0" i="1" smtClean="0">
                             <a:latin typeface="Cambria Math" panose="02040503050406030204" pitchFamily="18" charset="0"/>
                           </a:rPr>
                         </m:ctrlPr>
@@ -6456,7 +6710,7 @@
                         <m:sSub>
                           <m:sSubPr>
                             <m:ctrlPr>
-                              <a:rPr lang="nl-NL" i="1" smtClean="0">
+                              <a:rPr lang="nl-NL" i="1">
                                 <a:latin typeface="Cambria Math" panose="02040503050406030204" pitchFamily="18" charset="0"/>
                               </a:rPr>
                             </m:ctrlPr>
@@ -6559,6 +6813,7 @@
                         <m:ctrlPr>
                           <a:rPr lang="nl-NL" b="0" i="1" smtClean="0">
                             <a:latin typeface="Cambria Math" panose="02040503050406030204" pitchFamily="18" charset="0"/>
+                            <a:ea typeface="Cambria Math" panose="02040503050406030204" pitchFamily="18" charset="0"/>
                           </a:rPr>
                         </m:ctrlPr>
                       </m:sSubPr>
@@ -6622,6 +6877,7 @@
                         <m:ctrlPr>
                           <a:rPr lang="nl-NL" i="1">
                             <a:latin typeface="Cambria Math" panose="02040503050406030204" pitchFamily="18" charset="0"/>
+                            <a:ea typeface="Cambria Math" panose="02040503050406030204" pitchFamily="18" charset="0"/>
                           </a:rPr>
                         </m:ctrlPr>
                       </m:sSubPr>
@@ -6692,6 +6948,7 @@
                         <m:ctrlPr>
                           <a:rPr lang="nl-NL" i="1">
                             <a:latin typeface="Cambria Math" panose="02040503050406030204" pitchFamily="18" charset="0"/>
+                            <a:ea typeface="Cambria Math" panose="02040503050406030204" pitchFamily="18" charset="0"/>
                           </a:rPr>
                         </m:ctrlPr>
                       </m:sSubPr>
@@ -6780,6 +7037,7 @@
                         <m:ctrlPr>
                           <a:rPr lang="nl-NL" b="0" i="1" smtClean="0">
                             <a:latin typeface="Cambria Math" panose="02040503050406030204" pitchFamily="18" charset="0"/>
+                            <a:ea typeface="Cambria Math" panose="02040503050406030204" pitchFamily="18" charset="0"/>
                           </a:rPr>
                         </m:ctrlPr>
                       </m:sSubPr>
@@ -6806,6 +7064,7 @@
                         <m:ctrlPr>
                           <a:rPr lang="nl-NL" b="0" i="1" smtClean="0">
                             <a:latin typeface="Cambria Math" panose="02040503050406030204" pitchFamily="18" charset="0"/>
+                            <a:ea typeface="Cambria Math" panose="02040503050406030204" pitchFamily="18" charset="0"/>
                           </a:rPr>
                         </m:ctrlPr>
                       </m:sSubPr>
@@ -6844,6 +7103,7 @@
                         <m:ctrlPr>
                           <a:rPr lang="nl-NL" i="1">
                             <a:latin typeface="Cambria Math" panose="02040503050406030204" pitchFamily="18" charset="0"/>
+                            <a:ea typeface="Cambria Math" panose="02040503050406030204" pitchFamily="18" charset="0"/>
                           </a:rPr>
                         </m:ctrlPr>
                       </m:sSubPr>
@@ -6871,6 +7131,7 @@
                         <m:ctrlPr>
                           <a:rPr lang="nl-NL" i="1">
                             <a:latin typeface="Cambria Math" panose="02040503050406030204" pitchFamily="18" charset="0"/>
+                            <a:ea typeface="Cambria Math" panose="02040503050406030204" pitchFamily="18" charset="0"/>
                           </a:rPr>
                         </m:ctrlPr>
                       </m:sSubPr>
@@ -6909,6 +7170,7 @@
                         <m:ctrlPr>
                           <a:rPr lang="nl-NL" i="1">
                             <a:latin typeface="Cambria Math" panose="02040503050406030204" pitchFamily="18" charset="0"/>
+                            <a:ea typeface="Cambria Math" panose="02040503050406030204" pitchFamily="18" charset="0"/>
                           </a:rPr>
                         </m:ctrlPr>
                       </m:sSubPr>
@@ -6936,6 +7198,7 @@
                         <m:ctrlPr>
                           <a:rPr lang="nl-NL" i="1">
                             <a:latin typeface="Cambria Math" panose="02040503050406030204" pitchFamily="18" charset="0"/>
+                            <a:ea typeface="Cambria Math" panose="02040503050406030204" pitchFamily="18" charset="0"/>
                           </a:rPr>
                         </m:ctrlPr>
                       </m:sSubPr>
@@ -7038,6 +7301,7 @@
                         <m:ctrlPr>
                           <a:rPr lang="nl-NL" i="1">
                             <a:latin typeface="Cambria Math" panose="02040503050406030204" pitchFamily="18" charset="0"/>
+                            <a:ea typeface="Cambria Math" panose="02040503050406030204" pitchFamily="18" charset="0"/>
                           </a:rPr>
                         </m:ctrlPr>
                       </m:sSubPr>
@@ -7101,6 +7365,7 @@
                         <m:ctrlPr>
                           <a:rPr lang="nl-NL" i="1">
                             <a:latin typeface="Cambria Math" panose="02040503050406030204" pitchFamily="18" charset="0"/>
+                            <a:ea typeface="Cambria Math" panose="02040503050406030204" pitchFamily="18" charset="0"/>
                           </a:rPr>
                         </m:ctrlPr>
                       </m:sSubPr>
@@ -7127,6 +7392,7 @@
                         <m:ctrlPr>
                           <a:rPr lang="nl-NL" i="1">
                             <a:latin typeface="Cambria Math" panose="02040503050406030204" pitchFamily="18" charset="0"/>
+                            <a:ea typeface="Cambria Math" panose="02040503050406030204" pitchFamily="18" charset="0"/>
                           </a:rPr>
                         </m:ctrlPr>
                       </m:sSubPr>
@@ -7165,6 +7431,7 @@
                         <m:ctrlPr>
                           <a:rPr lang="nl-NL" i="1">
                             <a:latin typeface="Cambria Math" panose="02040503050406030204" pitchFamily="18" charset="0"/>
+                            <a:ea typeface="Cambria Math" panose="02040503050406030204" pitchFamily="18" charset="0"/>
                           </a:rPr>
                         </m:ctrlPr>
                       </m:sSubPr>
@@ -7229,6 +7496,7 @@
                         <m:ctrlPr>
                           <a:rPr lang="nl-NL" i="1">
                             <a:latin typeface="Cambria Math" panose="02040503050406030204" pitchFamily="18" charset="0"/>
+                            <a:ea typeface="Cambria Math" panose="02040503050406030204" pitchFamily="18" charset="0"/>
                           </a:rPr>
                         </m:ctrlPr>
                       </m:sSubPr>
@@ -7256,6 +7524,7 @@
                         <m:ctrlPr>
                           <a:rPr lang="nl-NL" i="1">
                             <a:latin typeface="Cambria Math" panose="02040503050406030204" pitchFamily="18" charset="0"/>
+                            <a:ea typeface="Cambria Math" panose="02040503050406030204" pitchFamily="18" charset="0"/>
                           </a:rPr>
                         </m:ctrlPr>
                       </m:sSubPr>
@@ -7294,6 +7563,7 @@
                         <m:ctrlPr>
                           <a:rPr lang="nl-NL" i="1">
                             <a:latin typeface="Cambria Math" panose="02040503050406030204" pitchFamily="18" charset="0"/>
+                            <a:ea typeface="Cambria Math" panose="02040503050406030204" pitchFamily="18" charset="0"/>
                           </a:rPr>
                         </m:ctrlPr>
                       </m:sSubPr>
@@ -7372,6 +7642,7 @@
                         <m:ctrlPr>
                           <a:rPr lang="nl-NL" i="1">
                             <a:latin typeface="Cambria Math" panose="02040503050406030204" pitchFamily="18" charset="0"/>
+                            <a:ea typeface="Cambria Math" panose="02040503050406030204" pitchFamily="18" charset="0"/>
                           </a:rPr>
                         </m:ctrlPr>
                       </m:sSubPr>
@@ -7399,6 +7670,7 @@
                         <m:ctrlPr>
                           <a:rPr lang="nl-NL" i="1">
                             <a:latin typeface="Cambria Math" panose="02040503050406030204" pitchFamily="18" charset="0"/>
+                            <a:ea typeface="Cambria Math" panose="02040503050406030204" pitchFamily="18" charset="0"/>
                           </a:rPr>
                         </m:ctrlPr>
                       </m:sSubPr>
@@ -7610,7 +7882,7 @@
             </p:txBody>
           </p:sp>
         </mc:Choice>
-        <mc:Fallback>
+        <mc:Fallback xmlns="">
           <p:sp>
             <p:nvSpPr>
               <p:cNvPr id="2" name="Tijdelijke aanduiding voor tekst 1">
@@ -8857,12 +9129,6 @@
 </file>
 
 <file path=customXml/item1.xml><?xml version="1.0" encoding="utf-8"?>
-<p:properties xmlns:p="http://schemas.microsoft.com/office/2006/metadata/properties" xmlns:xsi="http://www.w3.org/2001/XMLSchema-instance">
-  <documentManagement/>
-</p:properties>
-</file>
-
-<file path=customXml/item2.xml><?xml version="1.0" encoding="utf-8"?>
 <ct:contentTypeSchema xmlns:ct="http://schemas.microsoft.com/office/2006/metadata/contentType" xmlns:ma="http://schemas.microsoft.com/office/2006/metadata/properties/metaAttributes" ct:_="" ma:_="" ma:contentTypeName="Document" ma:contentTypeID="0x010100B2C6846675690041B0AEF76721A33550" ma:contentTypeVersion="12" ma:contentTypeDescription="Een nieuw document maken." ma:contentTypeScope="" ma:versionID="7d80b5b27cb88b7e670b1fbb7cd7de23">
   <xsd:schema xmlns:xsd="http://www.w3.org/2001/XMLSchema" xmlns:xs="http://www.w3.org/2001/XMLSchema" xmlns:p="http://schemas.microsoft.com/office/2006/metadata/properties" xmlns:ns2="6b01692f-8f45-4310-abfd-accd438f234f" xmlns:ns3="41d33a03-4c74-4b4d-8466-39dbc86d9cdb" targetNamespace="http://schemas.microsoft.com/office/2006/metadata/properties" ma:root="true" ma:fieldsID="2679454ac823c4dc22358f51a5683c7b" ns2:_="" ns3:_="">
     <xsd:import namespace="6b01692f-8f45-4310-abfd-accd438f234f"/>
@@ -9079,7 +9345,7 @@
 </ct:contentTypeSchema>
 </file>
 
-<file path=customXml/item3.xml><?xml version="1.0" encoding="utf-8"?>
+<file path=customXml/item2.xml><?xml version="1.0" encoding="utf-8"?>
 <?mso-contentType ?>
 <FormTemplates xmlns="http://schemas.microsoft.com/sharepoint/v3/contenttype/forms">
   <Display>DocumentLibraryForm</Display>
@@ -9088,24 +9354,13 @@
 </FormTemplates>
 </file>
 
-<file path=customXml/itemProps1.xml><?xml version="1.0" encoding="utf-8"?>
-<ds:datastoreItem xmlns:ds="http://schemas.openxmlformats.org/officeDocument/2006/customXml" ds:itemID="{665827D5-5A12-48FB-BA20-1E7CB9BA5BA1}">
-  <ds:schemaRefs>
-    <ds:schemaRef ds:uri="http://schemas.microsoft.com/office/2006/documentManagement/types"/>
-    <ds:schemaRef ds:uri="http://schemas.openxmlformats.org/package/2006/metadata/core-properties"/>
-    <ds:schemaRef ds:uri="http://purl.org/dc/elements/1.1/"/>
-    <ds:schemaRef ds:uri="http://schemas.microsoft.com/office/2006/metadata/properties"/>
-    <ds:schemaRef ds:uri="67c6fd78-9e9e-49b0-99f6-392b7eb0c25b"/>
-    <ds:schemaRef ds:uri="http://purl.org/dc/terms/"/>
-    <ds:schemaRef ds:uri="http://schemas.microsoft.com/office/infopath/2007/PartnerControls"/>
-    <ds:schemaRef ds:uri="53aadeef-871c-4d8b-955c-28f1a1590244"/>
-    <ds:schemaRef ds:uri="http://www.w3.org/XML/1998/namespace"/>
-    <ds:schemaRef ds:uri="http://purl.org/dc/dcmitype/"/>
-  </ds:schemaRefs>
-</ds:datastoreItem>
+<file path=customXml/item3.xml><?xml version="1.0" encoding="utf-8"?>
+<p:properties xmlns:p="http://schemas.microsoft.com/office/2006/metadata/properties" xmlns:xsi="http://www.w3.org/2001/XMLSchema-instance">
+  <documentManagement/>
+</p:properties>
 </file>
 
-<file path=customXml/itemProps2.xml><?xml version="1.0" encoding="utf-8"?>
+<file path=customXml/itemProps1.xml><?xml version="1.0" encoding="utf-8"?>
 <ds:datastoreItem xmlns:ds="http://schemas.openxmlformats.org/officeDocument/2006/customXml" ds:itemID="{E5A48691-3E40-4B9C-9CEF-B13064CE8A2A}">
   <ds:schemaRefs>
     <ds:schemaRef ds:uri="http://schemas.microsoft.com/office/2006/metadata/contentType"/>
@@ -9124,10 +9379,27 @@
 </ds:datastoreItem>
 </file>
 
-<file path=customXml/itemProps3.xml><?xml version="1.0" encoding="utf-8"?>
+<file path=customXml/itemProps2.xml><?xml version="1.0" encoding="utf-8"?>
 <ds:datastoreItem xmlns:ds="http://schemas.openxmlformats.org/officeDocument/2006/customXml" ds:itemID="{EE540D17-DFE7-4DA1-AB7C-9204237EF006}">
   <ds:schemaRefs>
     <ds:schemaRef ds:uri="http://schemas.microsoft.com/sharepoint/v3/contenttype/forms"/>
   </ds:schemaRefs>
 </ds:datastoreItem>
+</file>
+
+<file path=customXml/itemProps3.xml><?xml version="1.0" encoding="utf-8"?>
+<ds:datastoreItem xmlns:ds="http://schemas.openxmlformats.org/officeDocument/2006/customXml" ds:itemID="{665827D5-5A12-48FB-BA20-1E7CB9BA5BA1}">
+  <ds:schemaRefs>
+    <ds:schemaRef ds:uri="http://schemas.microsoft.com/office/2006/documentManagement/types"/>
+    <ds:schemaRef ds:uri="http://schemas.openxmlformats.org/package/2006/metadata/core-properties"/>
+    <ds:schemaRef ds:uri="http://purl.org/dc/elements/1.1/"/>
+    <ds:schemaRef ds:uri="http://schemas.microsoft.com/office/2006/metadata/properties"/>
+    <ds:schemaRef ds:uri="67c6fd78-9e9e-49b0-99f6-392b7eb0c25b"/>
+    <ds:schemaRef ds:uri="http://purl.org/dc/terms/"/>
+    <ds:schemaRef ds:uri="http://schemas.microsoft.com/office/infopath/2007/PartnerControls"/>
+    <ds:schemaRef ds:uri="53aadeef-871c-4d8b-955c-28f1a1590244"/>
+    <ds:schemaRef ds:uri="http://www.w3.org/XML/1998/namespace"/>
+    <ds:schemaRef ds:uri="http://purl.org/dc/dcmitype/"/>
+  </ds:schemaRefs>
+</ds:datastoreItem>
 </file>
</xml_diff>